<commit_message>
seminar 6장: Anderson Fig. 3d 크롭 정정 + 소불릿 한 문장으로
크롭 오류
  Anderson 2024 Fig. 3 은 세로 4패널 — (a) Total LLZO wt % · (b) Cubic LLZO wt %
  · (c) Bond valence mismatch · (d) Defect energy.
  앞 판은 0.695H 에서 잘라 (c) 의 x축 라벨 띠가 같이 들어갔고, 그래서 두 줄로 보이면서
  "defect energy" 라벨과 화면이 어긋났다. 0.762H ~ 1.0H 로 재크롭.

출처는 맞다 (확인)
  Fig. 3 캡션 원문: "d) The defect energy for each dopant obtained from Ref. [12]."
  digest: ref [12] = Miara, Richards, Wang, Ceder, Chem. Mater. 2015, 27, 4040
  → 그림은 Anderson 2024 의 것이고 그 안의 값은 Miara 2015 의 것. 둘 다 적어야 맞다.
  하단 캡션을 "as stated in that caption" 까지 넣어 근거를 명시했다.

소불릿
  괄호 줄 2개를 없애고 한 문장으로:
  "A dopant enters as a precursor, not an element, so a cation and an anion are placed at once."
  `not an element` 가 차별점을 세 단어로 진다 (표의 what-is-varied 열과 대응).

Co-Authored-By: Claude Opus 5 <noreply@anthropic.com>
Claude-Session: https://claude.ai/code/session_01L44TWYrHkcm4PH5ihWSSCw
</commit_message>
<xml_diff>
--- a/docs/Slide06_prior_stops.pptx
+++ b/docs/Slide06_prior_stops.pptx
@@ -1460,7 +1460,7 @@
         </p:nvSpPr>
         <p:spPr>
           <a:xfrm xmlns:a="http://schemas.openxmlformats.org/drawingml/2006/main">
-            <a:off x="942975" y="1847088"/>
+            <a:off x="942975" y="1810512"/>
             <a:ext cx="171450" cy="238125"/>
           </a:xfrm>
           <a:prstGeom xmlns:a="http://schemas.openxmlformats.org/drawingml/2006/main" prst="rect">
@@ -1518,7 +1518,7 @@
         </p:nvSpPr>
         <p:spPr>
           <a:xfrm xmlns:a="http://schemas.openxmlformats.org/drawingml/2006/main">
-            <a:off x="1219200" y="1847088"/>
+            <a:off x="1219200" y="1810512"/>
             <a:ext cx="7239000" cy="285750"/>
           </a:xfrm>
           <a:prstGeom xmlns:a="http://schemas.openxmlformats.org/drawingml/2006/main" prst="rect">
@@ -1555,7 +1555,7 @@
                 <a:ea typeface="Arial"/>
                 <a:cs typeface="Arial"/>
               </a:rPr>
-              <a:t>Here the unit is </a:t>
+              <a:t>A dopant enters as </a:t>
             </a:r>
             <a:r>
               <a:rPr sz="1275" b="1">
@@ -1566,7 +1566,7 @@
                 <a:ea typeface="Arial"/>
                 <a:cs typeface="Arial"/>
               </a:rPr>
-              <a:t>a precursor compound</a:t>
+              <a:t>a precursor, not an element</a:t>
             </a:r>
             <a:r>
               <a:rPr sz="1275" b="0">
@@ -1577,7 +1577,7 @@
                 <a:ea typeface="Arial"/>
                 <a:cs typeface="Arial"/>
               </a:rPr>
-              <a:t>, the way doping is actually done.</a:t>
+              <a:t>, so a cation and an anion are placed at once.</a:t>
             </a:r>
           </a:p>
         </p:txBody>
@@ -1635,7 +1635,7 @@
                 <a:ea typeface="Arial"/>
                 <a:cs typeface="Arial"/>
               </a:rPr>
-              <a:t>Lee 2024: J. Mater. Chem. A, 12, 7272.   Xiao 2019: Joule, 3, 1252.   Left figure: Anderson et al. (2024) Fig. 3d, plotting defect energies from Miara et al. (2015).</a:t>
+              <a:t>Lee 2024: J. Mater. Chem. A, 12, 7272.   Xiao 2019: Joule, 3, 1252.   Left: Anderson et al. (2024) Fig. 3d — defect energies taken from Miara et al. (2015), as stated in that caption.</a:t>
             </a:r>
           </a:p>
         </p:txBody>
@@ -1849,40 +1849,30 @@
           </a:p>
         </p:txBody>
       </p:sp>
-      <p:sp xmlns:a="http://schemas.openxmlformats.org/drawingml/2006/main">
-        <p:nvSpPr>
-          <p:cNvPr id="36" name="TextBox 35"/>
-          <p:cNvSpPr txBox="1"/>
+      <p:pic xmlns:a="http://schemas.openxmlformats.org/drawingml/2006/main" xmlns:r="http://schemas.openxmlformats.org/officeDocument/2006/relationships">
+        <p:nvPicPr>
+          <p:cNvPr id="36" name="Picture 35" descr="prior_site_defect_energy.png"/>
+          <p:cNvPicPr>
+            <a:picLocks noChangeAspect="1"/>
+          </p:cNvPicPr>
           <p:nvPr/>
-        </p:nvSpPr>
+        </p:nvPicPr>
+        <p:blipFill>
+          <a:blip r:embed="rId4"/>
+          <a:stretch>
+            <a:fillRect/>
+          </a:stretch>
+        </p:blipFill>
         <p:spPr>
           <a:xfrm>
-            <a:off x="1481328" y="1645920"/>
-            <a:ext cx="7040880" cy="237744"/>
+            <a:off x="566928" y="3385300"/>
+            <a:ext cx="3913632" cy="692923"/>
           </a:xfrm>
           <a:prstGeom prst="rect">
             <a:avLst/>
           </a:prstGeom>
-          <a:noFill/>
         </p:spPr>
-        <p:txBody>
-          <a:bodyPr wrap="none">
-            <a:spAutoFit/>
-          </a:bodyPr>
-          <a:lstStyle/>
-          <a:p>
-            <a:r>
-              <a:rPr sz="1100">
-                <a:solidFill>
-                  <a:srgbClr val="6B7280"/>
-                </a:solidFill>
-                <a:latin typeface="Arial"/>
-              </a:rPr>
-              <a:t>(Li site · La site · Zr site → the lowest defect energy wins)</a:t>
-            </a:r>
-          </a:p>
-        </p:txBody>
-      </p:sp>
+      </p:pic>
       <p:sp xmlns:a="http://schemas.openxmlformats.org/drawingml/2006/main">
         <p:nvSpPr>
           <p:cNvPr id="37" name="TextBox 36"/>
@@ -1891,99 +1881,7 @@
         </p:nvSpPr>
         <p:spPr>
           <a:xfrm>
-            <a:off x="1481328" y="2103120"/>
-            <a:ext cx="7040880" cy="237744"/>
-          </a:xfrm>
-          <a:prstGeom prst="rect">
-            <a:avLst/>
-          </a:prstGeom>
-          <a:noFill/>
-        </p:spPr>
-        <p:txBody>
-          <a:bodyPr wrap="none">
-            <a:spAutoFit/>
-          </a:bodyPr>
-          <a:lstStyle/>
-          <a:p>
-            <a:r>
-              <a:rPr sz="1100">
-                <a:solidFill>
-                  <a:srgbClr val="6B7280"/>
-                </a:solidFill>
-                <a:latin typeface="Arial"/>
-              </a:rPr>
-              <a:t>(Li₂S + P₂S₅ + LiCl  +  MgO → ball-mill → anneal)</a:t>
-            </a:r>
-          </a:p>
-        </p:txBody>
-      </p:sp>
-      <p:sp xmlns:a="http://schemas.openxmlformats.org/drawingml/2006/main">
-        <p:nvSpPr>
-          <p:cNvPr id="38" name="TextBox 37"/>
-          <p:cNvSpPr txBox="1"/>
-          <p:nvPr/>
-        </p:nvSpPr>
-        <p:spPr>
-          <a:xfrm>
-            <a:off x="1481328" y="2359152"/>
-            <a:ext cx="7040880" cy="237744"/>
-          </a:xfrm>
-          <a:prstGeom prst="rect">
-            <a:avLst/>
-          </a:prstGeom>
-          <a:noFill/>
-        </p:spPr>
-        <p:txBody>
-          <a:bodyPr wrap="none">
-            <a:spAutoFit/>
-          </a:bodyPr>
-          <a:lstStyle/>
-          <a:p>
-            <a:r>
-              <a:rPr sz="1100">
-                <a:solidFill>
-                  <a:srgbClr val="6B7280"/>
-                </a:solidFill>
-                <a:latin typeface="Arial"/>
-              </a:rPr>
-              <a:t>(a cation and an anion enter together → both sites chosen at once)</a:t>
-            </a:r>
-          </a:p>
-        </p:txBody>
-      </p:sp>
-      <p:pic xmlns:a="http://schemas.openxmlformats.org/drawingml/2006/main" xmlns:r="http://schemas.openxmlformats.org/officeDocument/2006/relationships">
-        <p:nvPicPr>
-          <p:cNvPr id="39" name="Picture 38" descr="image.png"/>
-          <p:cNvPicPr>
-            <a:picLocks noChangeAspect="1"/>
-          </p:cNvPicPr>
-          <p:nvPr/>
-        </p:nvPicPr>
-        <p:blipFill>
-          <a:blip r:embed="rId2"/>
-          <a:stretch>
-            <a:fillRect/>
-          </a:stretch>
-        </p:blipFill>
-        <p:spPr>
-          <a:xfrm>
-            <a:off x="566928" y="3337585"/>
-            <a:ext cx="3913632" cy="886942"/>
-          </a:xfrm>
-          <a:prstGeom prst="rect">
-            <a:avLst/>
-          </a:prstGeom>
-        </p:spPr>
-      </p:pic>
-      <p:sp xmlns:a="http://schemas.openxmlformats.org/drawingml/2006/main">
-        <p:nvSpPr>
-          <p:cNvPr id="40" name="TextBox 39"/>
-          <p:cNvSpPr txBox="1"/>
-          <p:nvPr/>
-        </p:nvSpPr>
-        <p:spPr>
-          <a:xfrm>
-            <a:off x="566928" y="4261104"/>
+            <a:off x="566928" y="4114800"/>
             <a:ext cx="3913632" cy="256032"/>
           </a:xfrm>
           <a:prstGeom prst="rect">
@@ -2012,13 +1910,13 @@
       </p:sp>
       <p:sp xmlns:a="http://schemas.openxmlformats.org/drawingml/2006/main">
         <p:nvSpPr>
-          <p:cNvPr id="41" name="TextBox 40"/>
+          <p:cNvPr id="38" name="TextBox 37"/>
           <p:cNvSpPr txBox="1"/>
           <p:nvPr/>
         </p:nvSpPr>
         <p:spPr>
           <a:xfrm>
-            <a:off x="566928" y="4498848"/>
+            <a:off x="566928" y="4352544"/>
             <a:ext cx="3913632" cy="274320"/>
           </a:xfrm>
           <a:prstGeom prst="rect">
@@ -2047,7 +1945,7 @@
       </p:sp>
       <p:pic xmlns:a="http://schemas.openxmlformats.org/drawingml/2006/main" xmlns:r="http://schemas.openxmlformats.org/officeDocument/2006/relationships">
         <p:nvPicPr>
-          <p:cNvPr id="42" name="Picture 41" descr="image.png"/>
+          <p:cNvPr id="39" name="Picture 38" descr="image.png"/>
           <p:cNvPicPr>
             <a:picLocks noChangeAspect="1"/>
           </p:cNvPicPr>
@@ -2061,8 +1959,8 @@
         </p:blipFill>
         <p:spPr>
           <a:xfrm>
-            <a:off x="5247240" y="2670048"/>
-            <a:ext cx="2746031" cy="1554480"/>
+            <a:off x="5118014" y="2377439"/>
+            <a:ext cx="3004482" cy="1700784"/>
           </a:xfrm>
           <a:prstGeom prst="rect">
             <a:avLst/>
@@ -2071,13 +1969,13 @@
       </p:pic>
       <p:sp xmlns:a="http://schemas.openxmlformats.org/drawingml/2006/main">
         <p:nvSpPr>
-          <p:cNvPr id="43" name="TextBox 42"/>
+          <p:cNvPr id="40" name="TextBox 39"/>
           <p:cNvSpPr txBox="1"/>
           <p:nvPr/>
         </p:nvSpPr>
         <p:spPr>
           <a:xfrm>
-            <a:off x="4663440" y="4261104"/>
+            <a:off x="4663440" y="4114800"/>
             <a:ext cx="3913632" cy="256032"/>
           </a:xfrm>
           <a:prstGeom prst="rect">
@@ -2106,13 +2004,13 @@
       </p:sp>
       <p:sp xmlns:a="http://schemas.openxmlformats.org/drawingml/2006/main">
         <p:nvSpPr>
-          <p:cNvPr id="44" name="TextBox 43"/>
+          <p:cNvPr id="41" name="TextBox 40"/>
           <p:cNvSpPr txBox="1"/>
           <p:nvPr/>
         </p:nvSpPr>
         <p:spPr>
           <a:xfrm>
-            <a:off x="4663440" y="4498848"/>
+            <a:off x="4663440" y="4352544"/>
             <a:ext cx="3913632" cy="274320"/>
           </a:xfrm>
           <a:prstGeom prst="rect">
@@ -2141,7 +2039,7 @@
       </p:sp>
       <p:graphicFrame xmlns:a="http://schemas.openxmlformats.org/drawingml/2006/main">
         <p:nvGraphicFramePr>
-          <p:cNvPr id="45" name="Table 44"/>
+          <p:cNvPr id="42" name="Table 41"/>
           <p:cNvGraphicFramePr>
             <a:graphicFrameLocks noGrp="1"/>
           </p:cNvGraphicFramePr>

</xml_diff>